<commit_message>
Root-cause deck: decisive sector test executed on SF, outcome A (cells healthy after rewrite)
Sectors 57 and 31 (unstable as found) erased, programmed with three patterns
and re-read five times each: zero mismatches; control sector 200 identical.
Sheet 13 rewritten with the result; fix 3 becomes a clean erase of the
settings partition; closing sheet updated. Test record holds counts only.

Co-Authored-By: Claude Fable 5.1 <noreply@anthropic.com>
</commit_message>
<xml_diff>
--- a/docs/presentations/Group9_ConfigLoss_RootCause.pptx
+++ b/docs/presentations/Group9_ConfigLoss_RootCause.pptx
@@ -799,7 +799,7 @@
           <a:lstStyle/>
           <a:p>
             <a:r>
-              <a:t>Say plainly that this test was not run yet and why. It takes two minutes once approved.</a:t>
+              <a:t>This is the sheet that settles the recruiter's question. Healthy cells, damaged by the conditions of the write. Say that the control sector behaved identically, which validates the method.</a:t>
             </a:r>
           </a:p>
         </p:txBody>
@@ -7939,7 +7939,7 @@
                 </a:solidFill>
                 <a:latin typeface="Cambria"/>
               </a:rPr>
-              <a:t>Marginal cells are specific to one chip and one history. SF is the carried, bench-tested unit that has been run flat most often; RG reverted once, on the night both died. The sector map is a property of SF's flash, not of the design, which is exactly why a hardware hypothesis was worth testing rather than dismissing.</a:t>
+              <a:t>Marginal cells are specific to one chip and one history. SF is the carried, bench-tested unit that has been run flat most often; RG reverted once, on the night both died. The sector map is a property of SF's history, not of the design, which is exactly why a hardware hypothesis was worth testing rather than dismissing.</a:t>
             </a:r>
           </a:p>
         </p:txBody>
@@ -8357,21 +8357,676 @@
                 </a:solidFill>
                 <a:latin typeface="Cambria"/>
               </a:rPr>
-              <a:t>THE DECISIVE TEST: DAMAGED OR DISTURBED?</a:t>
-            </a:r>
-          </a:p>
-        </p:txBody>
-      </p:sp>
-      <p:sp>
-        <p:nvSpPr>
-          <p:cNvPr id="10" name="Rectangle 9"/>
+              <a:t>THE DECISIVE TEST: DISTURBED, NOT DAMAGED</a:t>
+            </a:r>
+          </a:p>
+        </p:txBody>
+      </p:sp>
+      <p:graphicFrame>
+        <p:nvGraphicFramePr>
+          <p:cNvPr id="10" name="Table 9"/>
+          <p:cNvGraphicFramePr>
+            <a:graphicFrameLocks noGrp="1"/>
+          </p:cNvGraphicFramePr>
+          <p:nvPr/>
+        </p:nvGraphicFramePr>
+        <p:xfrm>
+          <a:off x="502920" y="1188720"/>
+          <a:ext cx="11155680" cy="1828800"/>
+        </p:xfrm>
+        <a:graphic>
+          <a:graphicData uri="http://schemas.openxmlformats.org/drawingml/2006/table">
+            <a:tbl>
+              <a:tblPr firstRow="1" bandRow="1">
+                <a:tableStyleId>{5C22544A-7EE6-4342-B048-85BDC9FD1C3A}</a:tableStyleId>
+              </a:tblPr>
+              <a:tblGrid>
+                <a:gridCol w="1554480"/>
+                <a:gridCol w="2377440"/>
+                <a:gridCol w="1371600"/>
+                <a:gridCol w="1463040"/>
+                <a:gridCol w="1463040"/>
+                <a:gridCol w="1554480"/>
+                <a:gridCol w="1371600"/>
+              </a:tblGrid>
+              <a:tr h="457200">
+                <a:tc>
+                  <a:txBody>
+                    <a:bodyPr/>
+                    <a:lstStyle/>
+                    <a:p>
+                      <a:r>
+                        <a:rPr sz="1050" b="1">
+                          <a:solidFill>
+                            <a:srgbClr val="FFFFFF"/>
+                          </a:solidFill>
+                          <a:latin typeface="Cambria"/>
+                        </a:rPr>
+                        <a:t>Sector</a:t>
+                      </a:r>
+                    </a:p>
+                  </a:txBody>
+                  <a:tcPr marL="73152" marR="73152" marT="27432" marB="27432">
+                    <a:solidFill>
+                      <a:srgbClr val="16213D"/>
+                    </a:solidFill>
+                  </a:tcPr>
+                </a:tc>
+                <a:tc>
+                  <a:txBody>
+                    <a:bodyPr/>
+                    <a:lstStyle/>
+                    <a:p>
+                      <a:r>
+                        <a:rPr sz="1050" b="1">
+                          <a:solidFill>
+                            <a:srgbClr val="FFFFFF"/>
+                          </a:solidFill>
+                          <a:latin typeface="Cambria"/>
+                        </a:rPr>
+                        <a:t>As found (3 reads)</a:t>
+                      </a:r>
+                    </a:p>
+                  </a:txBody>
+                  <a:tcPr marL="73152" marR="73152" marT="27432" marB="27432">
+                    <a:solidFill>
+                      <a:srgbClr val="16213D"/>
+                    </a:solidFill>
+                  </a:tcPr>
+                </a:tc>
+                <a:tc>
+                  <a:txBody>
+                    <a:bodyPr/>
+                    <a:lstStyle/>
+                    <a:p>
+                      <a:r>
+                        <a:rPr sz="1050" b="1">
+                          <a:solidFill>
+                            <a:srgbClr val="FFFFFF"/>
+                          </a:solidFill>
+                          <a:latin typeface="Cambria"/>
+                        </a:rPr>
+                        <a:t>After erase</a:t>
+                      </a:r>
+                    </a:p>
+                  </a:txBody>
+                  <a:tcPr marL="73152" marR="73152" marT="27432" marB="27432">
+                    <a:solidFill>
+                      <a:srgbClr val="16213D"/>
+                    </a:solidFill>
+                  </a:tcPr>
+                </a:tc>
+                <a:tc>
+                  <a:txBody>
+                    <a:bodyPr/>
+                    <a:lstStyle/>
+                    <a:p>
+                      <a:r>
+                        <a:rPr sz="1050" b="1">
+                          <a:solidFill>
+                            <a:srgbClr val="FFFFFF"/>
+                          </a:solidFill>
+                          <a:latin typeface="Cambria"/>
+                        </a:rPr>
+                        <a:t>Programmed 0x00</a:t>
+                      </a:r>
+                    </a:p>
+                  </a:txBody>
+                  <a:tcPr marL="73152" marR="73152" marT="27432" marB="27432">
+                    <a:solidFill>
+                      <a:srgbClr val="16213D"/>
+                    </a:solidFill>
+                  </a:tcPr>
+                </a:tc>
+                <a:tc>
+                  <a:txBody>
+                    <a:bodyPr/>
+                    <a:lstStyle/>
+                    <a:p>
+                      <a:r>
+                        <a:rPr sz="1050" b="1">
+                          <a:solidFill>
+                            <a:srgbClr val="FFFFFF"/>
+                          </a:solidFill>
+                          <a:latin typeface="Cambria"/>
+                        </a:rPr>
+                        <a:t>Programmed A5/5A</a:t>
+                      </a:r>
+                    </a:p>
+                  </a:txBody>
+                  <a:tcPr marL="73152" marR="73152" marT="27432" marB="27432">
+                    <a:solidFill>
+                      <a:srgbClr val="16213D"/>
+                    </a:solidFill>
+                  </a:tcPr>
+                </a:tc>
+                <a:tc>
+                  <a:txBody>
+                    <a:bodyPr/>
+                    <a:lstStyle/>
+                    <a:p>
+                      <a:r>
+                        <a:rPr sz="1050" b="1">
+                          <a:solidFill>
+                            <a:srgbClr val="FFFFFF"/>
+                          </a:solidFill>
+                          <a:latin typeface="Cambria"/>
+                        </a:rPr>
+                        <a:t>Programmed random</a:t>
+                      </a:r>
+                    </a:p>
+                  </a:txBody>
+                  <a:tcPr marL="73152" marR="73152" marT="27432" marB="27432">
+                    <a:solidFill>
+                      <a:srgbClr val="16213D"/>
+                    </a:solidFill>
+                  </a:tcPr>
+                </a:tc>
+                <a:tc>
+                  <a:txBody>
+                    <a:bodyPr/>
+                    <a:lstStyle/>
+                    <a:p>
+                      <a:r>
+                        <a:rPr sz="1050" b="1">
+                          <a:solidFill>
+                            <a:srgbClr val="FFFFFF"/>
+                          </a:solidFill>
+                          <a:latin typeface="Cambria"/>
+                        </a:rPr>
+                        <a:t>Erased again</a:t>
+                      </a:r>
+                    </a:p>
+                  </a:txBody>
+                  <a:tcPr marL="73152" marR="73152" marT="27432" marB="27432">
+                    <a:solidFill>
+                      <a:srgbClr val="16213D"/>
+                    </a:solidFill>
+                  </a:tcPr>
+                </a:tc>
+              </a:tr>
+              <a:tr h="457200">
+                <a:tc>
+                  <a:txBody>
+                    <a:bodyPr/>
+                    <a:lstStyle/>
+                    <a:p>
+                      <a:r>
+                        <a:rPr sz="1050" b="0">
+                          <a:solidFill>
+                            <a:srgbClr val="222A3F"/>
+                          </a:solidFill>
+                          <a:latin typeface="Cambria"/>
+                        </a:rPr>
+                        <a:t>57 (worst)</a:t>
+                      </a:r>
+                    </a:p>
+                  </a:txBody>
+                  <a:tcPr marL="73152" marR="73152" marT="27432" marB="27432">
+                    <a:solidFill>
+                      <a:srgbClr val="F2F5FA"/>
+                    </a:solidFill>
+                  </a:tcPr>
+                </a:tc>
+                <a:tc>
+                  <a:txBody>
+                    <a:bodyPr/>
+                    <a:lstStyle/>
+                    <a:p>
+                      <a:r>
+                        <a:rPr sz="1050" b="0">
+                          <a:solidFill>
+                            <a:srgbClr val="222A3F"/>
+                          </a:solidFill>
+                          <a:latin typeface="Cambria"/>
+                        </a:rPr>
+                        <a:t>unstable: 27 bytes disagree</a:t>
+                      </a:r>
+                    </a:p>
+                  </a:txBody>
+                  <a:tcPr marL="73152" marR="73152" marT="27432" marB="27432">
+                    <a:solidFill>
+                      <a:srgbClr val="F2F5FA"/>
+                    </a:solidFill>
+                  </a:tcPr>
+                </a:tc>
+                <a:tc>
+                  <a:txBody>
+                    <a:bodyPr/>
+                    <a:lstStyle/>
+                    <a:p>
+                      <a:r>
+                        <a:rPr sz="1050" b="0">
+                          <a:solidFill>
+                            <a:srgbClr val="222A3F"/>
+                          </a:solidFill>
+                          <a:latin typeface="Cambria"/>
+                        </a:rPr>
+                        <a:t>5/5 clean</a:t>
+                      </a:r>
+                    </a:p>
+                  </a:txBody>
+                  <a:tcPr marL="73152" marR="73152" marT="27432" marB="27432">
+                    <a:solidFill>
+                      <a:srgbClr val="F2F5FA"/>
+                    </a:solidFill>
+                  </a:tcPr>
+                </a:tc>
+                <a:tc>
+                  <a:txBody>
+                    <a:bodyPr/>
+                    <a:lstStyle/>
+                    <a:p>
+                      <a:r>
+                        <a:rPr sz="1050" b="0">
+                          <a:solidFill>
+                            <a:srgbClr val="222A3F"/>
+                          </a:solidFill>
+                          <a:latin typeface="Cambria"/>
+                        </a:rPr>
+                        <a:t>5/5 clean</a:t>
+                      </a:r>
+                    </a:p>
+                  </a:txBody>
+                  <a:tcPr marL="73152" marR="73152" marT="27432" marB="27432">
+                    <a:solidFill>
+                      <a:srgbClr val="F2F5FA"/>
+                    </a:solidFill>
+                  </a:tcPr>
+                </a:tc>
+                <a:tc>
+                  <a:txBody>
+                    <a:bodyPr/>
+                    <a:lstStyle/>
+                    <a:p>
+                      <a:r>
+                        <a:rPr sz="1050" b="0">
+                          <a:solidFill>
+                            <a:srgbClr val="222A3F"/>
+                          </a:solidFill>
+                          <a:latin typeface="Cambria"/>
+                        </a:rPr>
+                        <a:t>5/5 clean</a:t>
+                      </a:r>
+                    </a:p>
+                  </a:txBody>
+                  <a:tcPr marL="73152" marR="73152" marT="27432" marB="27432">
+                    <a:solidFill>
+                      <a:srgbClr val="F2F5FA"/>
+                    </a:solidFill>
+                  </a:tcPr>
+                </a:tc>
+                <a:tc>
+                  <a:txBody>
+                    <a:bodyPr/>
+                    <a:lstStyle/>
+                    <a:p>
+                      <a:r>
+                        <a:rPr sz="1050" b="0">
+                          <a:solidFill>
+                            <a:srgbClr val="222A3F"/>
+                          </a:solidFill>
+                          <a:latin typeface="Cambria"/>
+                        </a:rPr>
+                        <a:t>5/5 clean</a:t>
+                      </a:r>
+                    </a:p>
+                  </a:txBody>
+                  <a:tcPr marL="73152" marR="73152" marT="27432" marB="27432">
+                    <a:solidFill>
+                      <a:srgbClr val="F2F5FA"/>
+                    </a:solidFill>
+                  </a:tcPr>
+                </a:tc>
+                <a:tc>
+                  <a:txBody>
+                    <a:bodyPr/>
+                    <a:lstStyle/>
+                    <a:p>
+                      <a:r>
+                        <a:rPr sz="1050" b="0">
+                          <a:solidFill>
+                            <a:srgbClr val="222A3F"/>
+                          </a:solidFill>
+                          <a:latin typeface="Cambria"/>
+                        </a:rPr>
+                        <a:t>5/5 clean</a:t>
+                      </a:r>
+                    </a:p>
+                  </a:txBody>
+                  <a:tcPr marL="73152" marR="73152" marT="27432" marB="27432">
+                    <a:solidFill>
+                      <a:srgbClr val="F2F5FA"/>
+                    </a:solidFill>
+                  </a:tcPr>
+                </a:tc>
+              </a:tr>
+              <a:tr h="457200">
+                <a:tc>
+                  <a:txBody>
+                    <a:bodyPr/>
+                    <a:lstStyle/>
+                    <a:p>
+                      <a:r>
+                        <a:rPr sz="1050" b="0">
+                          <a:solidFill>
+                            <a:srgbClr val="222A3F"/>
+                          </a:solidFill>
+                          <a:latin typeface="Cambria"/>
+                        </a:rPr>
+                        <a:t>31</a:t>
+                      </a:r>
+                    </a:p>
+                  </a:txBody>
+                  <a:tcPr marL="73152" marR="73152" marT="27432" marB="27432">
+                    <a:solidFill>
+                      <a:srgbClr val="FFFFFF"/>
+                    </a:solidFill>
+                  </a:tcPr>
+                </a:tc>
+                <a:tc>
+                  <a:txBody>
+                    <a:bodyPr/>
+                    <a:lstStyle/>
+                    <a:p>
+                      <a:r>
+                        <a:rPr sz="1050" b="0">
+                          <a:solidFill>
+                            <a:srgbClr val="222A3F"/>
+                          </a:solidFill>
+                          <a:latin typeface="Cambria"/>
+                        </a:rPr>
+                        <a:t>unstable: 20 bytes disagree</a:t>
+                      </a:r>
+                    </a:p>
+                  </a:txBody>
+                  <a:tcPr marL="73152" marR="73152" marT="27432" marB="27432">
+                    <a:solidFill>
+                      <a:srgbClr val="FFFFFF"/>
+                    </a:solidFill>
+                  </a:tcPr>
+                </a:tc>
+                <a:tc>
+                  <a:txBody>
+                    <a:bodyPr/>
+                    <a:lstStyle/>
+                    <a:p>
+                      <a:r>
+                        <a:rPr sz="1050" b="0">
+                          <a:solidFill>
+                            <a:srgbClr val="222A3F"/>
+                          </a:solidFill>
+                          <a:latin typeface="Cambria"/>
+                        </a:rPr>
+                        <a:t>5/5 clean</a:t>
+                      </a:r>
+                    </a:p>
+                  </a:txBody>
+                  <a:tcPr marL="73152" marR="73152" marT="27432" marB="27432">
+                    <a:solidFill>
+                      <a:srgbClr val="FFFFFF"/>
+                    </a:solidFill>
+                  </a:tcPr>
+                </a:tc>
+                <a:tc>
+                  <a:txBody>
+                    <a:bodyPr/>
+                    <a:lstStyle/>
+                    <a:p>
+                      <a:r>
+                        <a:rPr sz="1050" b="0">
+                          <a:solidFill>
+                            <a:srgbClr val="222A3F"/>
+                          </a:solidFill>
+                          <a:latin typeface="Cambria"/>
+                        </a:rPr>
+                        <a:t>5/5 clean</a:t>
+                      </a:r>
+                    </a:p>
+                  </a:txBody>
+                  <a:tcPr marL="73152" marR="73152" marT="27432" marB="27432">
+                    <a:solidFill>
+                      <a:srgbClr val="FFFFFF"/>
+                    </a:solidFill>
+                  </a:tcPr>
+                </a:tc>
+                <a:tc>
+                  <a:txBody>
+                    <a:bodyPr/>
+                    <a:lstStyle/>
+                    <a:p>
+                      <a:r>
+                        <a:rPr sz="1050" b="0">
+                          <a:solidFill>
+                            <a:srgbClr val="222A3F"/>
+                          </a:solidFill>
+                          <a:latin typeface="Cambria"/>
+                        </a:rPr>
+                        <a:t>5/5 clean</a:t>
+                      </a:r>
+                    </a:p>
+                  </a:txBody>
+                  <a:tcPr marL="73152" marR="73152" marT="27432" marB="27432">
+                    <a:solidFill>
+                      <a:srgbClr val="FFFFFF"/>
+                    </a:solidFill>
+                  </a:tcPr>
+                </a:tc>
+                <a:tc>
+                  <a:txBody>
+                    <a:bodyPr/>
+                    <a:lstStyle/>
+                    <a:p>
+                      <a:r>
+                        <a:rPr sz="1050" b="0">
+                          <a:solidFill>
+                            <a:srgbClr val="222A3F"/>
+                          </a:solidFill>
+                          <a:latin typeface="Cambria"/>
+                        </a:rPr>
+                        <a:t>5/5 clean</a:t>
+                      </a:r>
+                    </a:p>
+                  </a:txBody>
+                  <a:tcPr marL="73152" marR="73152" marT="27432" marB="27432">
+                    <a:solidFill>
+                      <a:srgbClr val="FFFFFF"/>
+                    </a:solidFill>
+                  </a:tcPr>
+                </a:tc>
+                <a:tc>
+                  <a:txBody>
+                    <a:bodyPr/>
+                    <a:lstStyle/>
+                    <a:p>
+                      <a:r>
+                        <a:rPr sz="1050" b="0">
+                          <a:solidFill>
+                            <a:srgbClr val="222A3F"/>
+                          </a:solidFill>
+                          <a:latin typeface="Cambria"/>
+                        </a:rPr>
+                        <a:t>5/5 clean</a:t>
+                      </a:r>
+                    </a:p>
+                  </a:txBody>
+                  <a:tcPr marL="73152" marR="73152" marT="27432" marB="27432">
+                    <a:solidFill>
+                      <a:srgbClr val="FFFFFF"/>
+                    </a:solidFill>
+                  </a:tcPr>
+                </a:tc>
+              </a:tr>
+              <a:tr h="457200">
+                <a:tc>
+                  <a:txBody>
+                    <a:bodyPr/>
+                    <a:lstStyle/>
+                    <a:p>
+                      <a:r>
+                        <a:rPr sz="1050" b="0">
+                          <a:solidFill>
+                            <a:srgbClr val="222A3F"/>
+                          </a:solidFill>
+                          <a:latin typeface="Cambria"/>
+                        </a:rPr>
+                        <a:t>200 (control, free)</a:t>
+                      </a:r>
+                    </a:p>
+                  </a:txBody>
+                  <a:tcPr marL="73152" marR="73152" marT="27432" marB="27432">
+                    <a:solidFill>
+                      <a:srgbClr val="F2F5FA"/>
+                    </a:solidFill>
+                  </a:tcPr>
+                </a:tc>
+                <a:tc>
+                  <a:txBody>
+                    <a:bodyPr/>
+                    <a:lstStyle/>
+                    <a:p>
+                      <a:r>
+                        <a:rPr sz="1050" b="0">
+                          <a:solidFill>
+                            <a:srgbClr val="222A3F"/>
+                          </a:solidFill>
+                          <a:latin typeface="Cambria"/>
+                        </a:rPr>
+                        <a:t>stable: 0</a:t>
+                      </a:r>
+                    </a:p>
+                  </a:txBody>
+                  <a:tcPr marL="73152" marR="73152" marT="27432" marB="27432">
+                    <a:solidFill>
+                      <a:srgbClr val="F2F5FA"/>
+                    </a:solidFill>
+                  </a:tcPr>
+                </a:tc>
+                <a:tc>
+                  <a:txBody>
+                    <a:bodyPr/>
+                    <a:lstStyle/>
+                    <a:p>
+                      <a:r>
+                        <a:rPr sz="1050" b="0">
+                          <a:solidFill>
+                            <a:srgbClr val="222A3F"/>
+                          </a:solidFill>
+                          <a:latin typeface="Cambria"/>
+                        </a:rPr>
+                        <a:t>5/5 clean</a:t>
+                      </a:r>
+                    </a:p>
+                  </a:txBody>
+                  <a:tcPr marL="73152" marR="73152" marT="27432" marB="27432">
+                    <a:solidFill>
+                      <a:srgbClr val="F2F5FA"/>
+                    </a:solidFill>
+                  </a:tcPr>
+                </a:tc>
+                <a:tc>
+                  <a:txBody>
+                    <a:bodyPr/>
+                    <a:lstStyle/>
+                    <a:p>
+                      <a:r>
+                        <a:rPr sz="1050" b="0">
+                          <a:solidFill>
+                            <a:srgbClr val="222A3F"/>
+                          </a:solidFill>
+                          <a:latin typeface="Cambria"/>
+                        </a:rPr>
+                        <a:t>5/5 clean</a:t>
+                      </a:r>
+                    </a:p>
+                  </a:txBody>
+                  <a:tcPr marL="73152" marR="73152" marT="27432" marB="27432">
+                    <a:solidFill>
+                      <a:srgbClr val="F2F5FA"/>
+                    </a:solidFill>
+                  </a:tcPr>
+                </a:tc>
+                <a:tc>
+                  <a:txBody>
+                    <a:bodyPr/>
+                    <a:lstStyle/>
+                    <a:p>
+                      <a:r>
+                        <a:rPr sz="1050" b="0">
+                          <a:solidFill>
+                            <a:srgbClr val="222A3F"/>
+                          </a:solidFill>
+                          <a:latin typeface="Cambria"/>
+                        </a:rPr>
+                        <a:t>5/5 clean</a:t>
+                      </a:r>
+                    </a:p>
+                  </a:txBody>
+                  <a:tcPr marL="73152" marR="73152" marT="27432" marB="27432">
+                    <a:solidFill>
+                      <a:srgbClr val="F2F5FA"/>
+                    </a:solidFill>
+                  </a:tcPr>
+                </a:tc>
+                <a:tc>
+                  <a:txBody>
+                    <a:bodyPr/>
+                    <a:lstStyle/>
+                    <a:p>
+                      <a:r>
+                        <a:rPr sz="1050" b="0">
+                          <a:solidFill>
+                            <a:srgbClr val="222A3F"/>
+                          </a:solidFill>
+                          <a:latin typeface="Cambria"/>
+                        </a:rPr>
+                        <a:t>5/5 clean</a:t>
+                      </a:r>
+                    </a:p>
+                  </a:txBody>
+                  <a:tcPr marL="73152" marR="73152" marT="27432" marB="27432">
+                    <a:solidFill>
+                      <a:srgbClr val="F2F5FA"/>
+                    </a:solidFill>
+                  </a:tcPr>
+                </a:tc>
+                <a:tc>
+                  <a:txBody>
+                    <a:bodyPr/>
+                    <a:lstStyle/>
+                    <a:p>
+                      <a:r>
+                        <a:rPr sz="1050" b="0">
+                          <a:solidFill>
+                            <a:srgbClr val="222A3F"/>
+                          </a:solidFill>
+                          <a:latin typeface="Cambria"/>
+                        </a:rPr>
+                        <a:t>5/5 clean</a:t>
+                      </a:r>
+                    </a:p>
+                  </a:txBody>
+                  <a:tcPr marL="73152" marR="73152" marT="27432" marB="27432">
+                    <a:solidFill>
+                      <a:srgbClr val="F2F5FA"/>
+                    </a:solidFill>
+                  </a:tcPr>
+                </a:tc>
+              </a:tr>
+            </a:tbl>
+          </a:graphicData>
+        </a:graphic>
+      </p:graphicFrame>
+      <p:sp>
+        <p:nvSpPr>
+          <p:cNvPr id="11" name="Rectangle 10"/>
           <p:cNvSpPr/>
           <p:nvPr/>
         </p:nvSpPr>
         <p:spPr>
           <a:xfrm>
-            <a:off x="502920" y="1234440"/>
-            <a:ext cx="5486400" cy="2377440"/>
+            <a:off x="502920" y="3200400"/>
+            <a:ext cx="5486400" cy="2788920"/>
           </a:xfrm>
           <a:prstGeom prst="rect">
             <a:avLst/>
@@ -8410,14 +9065,14 @@
       </p:sp>
       <p:sp>
         <p:nvSpPr>
-          <p:cNvPr id="11" name="TextBox 10"/>
+          <p:cNvPr id="12" name="TextBox 11"/>
           <p:cNvSpPr txBox="1"/>
           <p:nvPr/>
         </p:nvSpPr>
         <p:spPr>
           <a:xfrm>
-            <a:off x="667512" y="1353312"/>
-            <a:ext cx="5157216" cy="2139696"/>
+            <a:off x="667512" y="3319272"/>
+            <a:ext cx="5157216" cy="2551176"/>
           </a:xfrm>
           <a:prstGeom prst="rect">
             <a:avLst/>
@@ -8437,7 +9092,7 @@
                 </a:solidFill>
                 <a:latin typeface="Cambria"/>
               </a:rPr>
-              <a:t>PROCEDURE (SF, SECTORS 57 AND 31; CONTROL SECTOR 200)</a:t>
+              <a:t>WHAT WAS DONE (SF, 2026-10-27, AUTHORISED)</a:t>
             </a:r>
           </a:p>
           <a:p>
@@ -8448,21 +9103,21 @@
                 </a:solidFill>
                 <a:latin typeface="Cambria"/>
               </a:rPr>
-              <a:t>Erase the sector; program all-zeros; read five times. Erase; program a 0xA5/0x5A pattern; read five times. Erase; program a fixed random page; read five times. Erase and leave free. The three test sectors hold no live data (LittleFS lists them as free), so the filesystem is untouched; the radio's configuration is backed up in the config snapshot regardless.</a:t>
-            </a:r>
-          </a:p>
-        </p:txBody>
-      </p:sp>
-      <p:sp>
-        <p:nvSpPr>
-          <p:cNvPr id="12" name="Rectangle 11"/>
+              <a:t>Each sector: read three times as found; erase; program all-zeros and read five times; erase; program 0xA5/0x5A and read five times; erase; program a fixed random page and read five times; erase and leave free. Sector 200, which had never been written, served as the control. The sectors were free in LittleFS (its live data is in sectors 0, 1, 25, 26 and 470), so the configuration was untouched; the radio booted normally afterwards. Record: docs/src/flash_forensics/decisive_test_2026-10-27.json.</a:t>
+            </a:r>
+          </a:p>
+        </p:txBody>
+      </p:sp>
+      <p:sp>
+        <p:nvSpPr>
+          <p:cNvPr id="13" name="Rectangle 12"/>
           <p:cNvSpPr/>
           <p:nvPr/>
         </p:nvSpPr>
         <p:spPr>
           <a:xfrm>
-            <a:off x="6172200" y="1234440"/>
-            <a:ext cx="5486400" cy="2377440"/>
+            <a:off x="6172200" y="3200400"/>
+            <a:ext cx="5486400" cy="2788920"/>
           </a:xfrm>
           <a:prstGeom prst="rect">
             <a:avLst/>
@@ -8501,14 +9156,14 @@
       </p:sp>
       <p:sp>
         <p:nvSpPr>
-          <p:cNvPr id="13" name="TextBox 12"/>
+          <p:cNvPr id="14" name="TextBox 13"/>
           <p:cNvSpPr txBox="1"/>
           <p:nvPr/>
         </p:nvSpPr>
         <p:spPr>
           <a:xfrm>
-            <a:off x="6336792" y="1353312"/>
-            <a:ext cx="5157216" cy="2139696"/>
+            <a:off x="6336792" y="3319272"/>
+            <a:ext cx="5157216" cy="2551176"/>
           </a:xfrm>
           <a:prstGeom prst="rect">
             <a:avLst/>
@@ -8528,7 +9183,7 @@
                 </a:solidFill>
                 <a:latin typeface="Cambria"/>
               </a:rPr>
-              <a:t>OUTCOMES</a:t>
+              <a:t>WHAT IT MEANS</a:t>
             </a:r>
           </a:p>
           <a:p>
@@ -8539,99 +9194,7 @@
                 </a:solidFill>
                 <a:latin typeface="Cambria"/>
               </a:rPr>
-              <a:t>A. All reads match every pattern: the cells are healthy and the instability was the residue of interrupted writes. Fix = clear the partition once under good voltage and stop the low-voltage writes.
-B. Mismatches persist: the cells are weak. Fix = avoid them (custom partition offset) or retire SF's flash, plus the same write-policy changes.</a:t>
-            </a:r>
-          </a:p>
-        </p:txBody>
-      </p:sp>
-      <p:sp>
-        <p:nvSpPr>
-          <p:cNvPr id="14" name="Rectangle 13"/>
-          <p:cNvSpPr/>
-          <p:nvPr/>
-        </p:nvSpPr>
-        <p:spPr>
-          <a:xfrm>
-            <a:off x="502920" y="3840480"/>
-            <a:ext cx="11155680" cy="2148840"/>
-          </a:xfrm>
-          <a:prstGeom prst="rect">
-            <a:avLst/>
-          </a:prstGeom>
-          <a:solidFill>
-            <a:srgbClr val="F2F5FA"/>
-          </a:solidFill>
-          <a:ln w="15875">
-            <a:solidFill>
-              <a:srgbClr val="E58E1A"/>
-            </a:solidFill>
-          </a:ln>
-          <a:effectLst/>
-        </p:spPr>
-        <p:style>
-          <a:lnRef idx="1">
-            <a:schemeClr val="accent1"/>
-          </a:lnRef>
-          <a:fillRef idx="3">
-            <a:schemeClr val="accent1"/>
-          </a:fillRef>
-          <a:effectRef idx="2">
-            <a:schemeClr val="accent1"/>
-          </a:effectRef>
-          <a:fontRef idx="minor">
-            <a:schemeClr val="lt1"/>
-          </a:fontRef>
-        </p:style>
-        <p:txBody>
-          <a:bodyPr rtlCol="0" anchor="ctr"/>
-          <a:lstStyle/>
-          <a:p>
-            <a:pPr algn="ctr"/>
-          </a:p>
-        </p:txBody>
-      </p:sp>
-      <p:sp>
-        <p:nvSpPr>
-          <p:cNvPr id="15" name="TextBox 14"/>
-          <p:cNvSpPr txBox="1"/>
-          <p:nvPr/>
-        </p:nvSpPr>
-        <p:spPr>
-          <a:xfrm>
-            <a:off x="667512" y="3959352"/>
-            <a:ext cx="10826496" cy="1911095"/>
-          </a:xfrm>
-          <a:prstGeom prst="rect">
-            <a:avLst/>
-          </a:prstGeom>
-          <a:noFill/>
-        </p:spPr>
-        <p:txBody>
-          <a:bodyPr wrap="square" lIns="0" rIns="0" tIns="0" bIns="0">
-            <a:spAutoFit/>
-          </a:bodyPr>
-          <a:lstStyle/>
-          <a:p>
-            <a:r>
-              <a:rPr sz="1300" b="1" spc="100">
-                <a:solidFill>
-                  <a:srgbClr val="E58E1A"/>
-                </a:solidFill>
-                <a:latin typeface="Cambria"/>
-              </a:rPr>
-              <a:t>STATUS</a:t>
-            </a:r>
-          </a:p>
-          <a:p>
-            <a:r>
-              <a:rPr sz="1200">
-                <a:solidFill>
-                  <a:srgbClr val="222A3F"/>
-                </a:solidFill>
-                <a:latin typeface="Cambria"/>
-              </a:rPr>
-              <a:t>Designed and scripted on 2026-10-27; execution awaits sign-off because it writes to the radio's flash, even though only to free sectors. The same read-stability measurement should be run on RG (not on USB today) to see whether a radio with one loss shows a clean map; the comparison is itself evidence. Both results drop straight into sheets 10 to 12.</a:t>
+              <a:t>Outcome A. The cells program, erase and hold every pattern perfectly once written under a healthy supply: there is nothing wrong with the silicon. The instability we measured was the physical residue of earlier writes completed while the supply was outside the flash's operating range, exactly the mechanism the datasheet forbids and the firmware does not guard against. This closes the hardware question: not a defective or worn part, but a part that was written to under conditions in which no flash is specified to work. The repair for the sectors already affected is simple: one clean erase of the settings partition under USB power, then re-provision from the snapshot.</a:t>
             </a:r>
           </a:p>
         </p:txBody>
@@ -10064,7 +10627,7 @@
                           </a:solidFill>
                           <a:latin typeface="Cambria"/>
                         </a:rPr>
-                        <a:t>Clear or avoid the marginal sectors</a:t>
+                        <a:t>Clear the marginal sectors (outcome A confirmed)</a:t>
                       </a:r>
                     </a:p>
                   </a:txBody>
@@ -10086,7 +10649,7 @@
                           </a:solidFill>
                           <a:latin typeface="Cambria"/>
                         </a:rPr>
-                        <a:t>After the decisive test: erase the settings partition under USB power and re-provision from the snapshot (outcome A), or move the LittleFS partition past the bad cluster (outcome B).</a:t>
+                        <a:t>One clean erase of the settings partition (0xC90000, 3.4 MB) on USB power, then re-provision from the config snapshot with --configure; re-measure the sector map afterwards. Repeat on RG after its baseline map.</a:t>
                       </a:r>
                     </a:p>
                   </a:txBody>
@@ -10108,7 +10671,7 @@
                           </a:solidFill>
                           <a:latin typeface="Cambria"/>
                         </a:rPr>
-                        <a:t>2 hours</a:t>
+                        <a:t>30 minutes per radio</a:t>
                       </a:r>
                     </a:p>
                   </a:txBody>
@@ -10130,7 +10693,7 @@
                           </a:solidFill>
                           <a:latin typeface="Cambria"/>
                         </a:rPr>
-                        <a:t>Deo / Victor</a:t>
+                        <a:t>Deo</a:t>
                       </a:r>
                     </a:p>
                   </a:txBody>
@@ -11600,7 +12163,7 @@
                           </a:solidFill>
                           <a:latin typeface="Cambria"/>
                         </a:rPr>
-                        <a:t>Decisive sector test on SF (sheet 13)</a:t>
+                        <a:t>Decisive sector test on SF (sheet 13): done 2026-10-27</a:t>
                       </a:r>
                     </a:p>
                   </a:txBody>
@@ -11622,7 +12185,7 @@
                           </a:solidFill>
                           <a:latin typeface="Cambria"/>
                         </a:rPr>
-                        <a:t>Outcome A or B recorded; fix 3 chosen accordingly</a:t>
+                        <a:t>Outcome A: cells healthy after rewrite; fix 3 = clean erase</a:t>
                       </a:r>
                     </a:p>
                   </a:txBody>
@@ -12332,7 +12895,7 @@
                 </a:solidFill>
                 <a:latin typeface="Cambria"/>
               </a:rPr>
-              <a:t>Partly, and measurably. SF's settings partition contains 21 sectors (12 of them heavily) whose cells do not hold a definite value today; the program partition, the NVS partition and the bootloader are perfectly stable. But the chip is not worn (millions of boots of headroom) and the pattern follows power events, not time. The most probable history is that writes were completed while the supply had fallen below the flash's 2.7 V minimum but above the 2.44 V reset point, a window the firmware never checks before writing and then punishes by installing factory defaults.</a:t>
+              <a:t>Partly, and measurably, but not in the way the question implies. SF's settings partition held 21 sectors (12 heavily) whose cells did not return a definite value, while the program partition, NVS and bootloader were perfectly stable. Erasing and reprogramming those sectors under a healthy supply made them perfect again: the silicon is sound and not worn. The cells had been left half-written by operations completed while the supply was below the flash's 2.7 V minimum but above the 2.44 V reset point, a window the firmware never checks before writing and then punishes by installing factory defaults.</a:t>
             </a:r>
           </a:p>
         </p:txBody>
@@ -12413,7 +12976,7 @@
                 </a:solidFill>
                 <a:latin typeface="Cambria"/>
               </a:rPr>
-              <a:t>21</a:t>
+              <a:t>21 -&gt; 0</a:t>
             </a:r>
           </a:p>
         </p:txBody>
@@ -12448,7 +13011,7 @@
                 </a:solidFill>
                 <a:latin typeface="Cambria"/>
               </a:rPr>
-              <a:t>sectors of SF's settings flash read unstably today (12 heavily); 0 in 1 MB of code</a:t>
+              <a:t>unstable sectors in SF's settings flash, before and after one clean erase and reprogram</a:t>
             </a:r>
           </a:p>
         </p:txBody>
@@ -12875,7 +13438,7 @@
                 </a:solidFill>
                 <a:latin typeface="Cambria"/>
               </a:rPr>
-              <a:t>THE MEMORY SHOWS THE SCAR; THE POWER RAIL MADE IT; THE FIRMWARE MADE IT PERMANENT. ALL THREE ARE FIXABLE.</a:t>
+              <a:t>THE MEMORY BORE THE SCAR AND HEALS WHEN REWRITTEN; THE POWER RAIL MADE IT; THE FIRMWARE MADE IT PERMANENT. ALL THREE ARE FIXABLE.</a:t>
             </a:r>
           </a:p>
         </p:txBody>

</xml_diff>

<commit_message>
SF settings partition cleanly erased and re-provisioned; flash now reads 0 unstable sectors
Erase of 0xC90000..0xFF0000 on USB power, firmware re-formatted LittleFS,
snapshot re-applied with --configure in two passes (the region write
reboots the radio mid-transaction), read-back correct and persistent, node
key pair preserved; re-measured 0 differing bytes across three reads.
Deck sheets 13/15/17/18, User Guide 12.2 (run --configure twice), manual
scar entry 2 and two verification rows updated; PDFs rebuilt.

Co-Authored-By: Claude Fable 5.1 <noreply@anthropic.com>
</commit_message>
<xml_diff>
--- a/docs/presentations/Group9_ConfigLoss_RootCause.pptx
+++ b/docs/presentations/Group9_ConfigLoss_RootCause.pptx
@@ -9194,7 +9194,7 @@
                 </a:solidFill>
                 <a:latin typeface="Cambria"/>
               </a:rPr>
-              <a:t>Outcome A. The cells program, erase and hold every pattern perfectly once written under a healthy supply: there is nothing wrong with the silicon. The instability we measured was the physical residue of earlier writes completed while the supply was outside the flash's operating range, exactly the mechanism the datasheet forbids and the firmware does not guard against. This closes the hardware question: not a defective or worn part, but a part that was written to under conditions in which no flash is specified to work. The repair for the sectors already affected is simple: one clean erase of the settings partition under USB power, then re-provision from the snapshot.</a:t>
+              <a:t>Outcome A. The cells program, erase and hold every pattern perfectly once written under a healthy supply: there is nothing wrong with the silicon. The instability we measured was the physical residue of earlier writes completed while the supply was outside the flash's operating range, exactly the mechanism the datasheet forbids and the firmware does not guard against. This closes the hardware question: not a defective or worn part, but a part that was written to under conditions in which no flash is specified to work. The repair was then carried out the same day: one clean erase of the settings partition under USB power, LittleFS re-formatted by the firmware, snapshot re-applied; the partition now reads with zero differing bytes across three passes.</a:t>
             </a:r>
           </a:p>
         </p:txBody>
@@ -10627,7 +10627,7 @@
                           </a:solidFill>
                           <a:latin typeface="Cambria"/>
                         </a:rPr>
-                        <a:t>Clear the marginal sectors (outcome A confirmed)</a:t>
+                        <a:t>Clear the marginal sectors: DONE on SF 2026-10-27</a:t>
                       </a:r>
                     </a:p>
                   </a:txBody>
@@ -10649,7 +10649,7 @@
                           </a:solidFill>
                           <a:latin typeface="Cambria"/>
                         </a:rPr>
-                        <a:t>One clean erase of the settings partition (0xC90000, 3.4 MB) on USB power, then re-provision from the config snapshot with --configure; re-measure the sector map afterwards. Repeat on RG after its baseline map.</a:t>
+                        <a:t>Settings partition (0xC90000, 3.4 MB) erased on USB power; firmware re-formatted LittleFS; snapshot re-applied with --configure (two passes: the region write reboots the radio mid-transaction, so the second pass is mandatory); read-back correct and persistent; node key pair preserved. Re-measured: 0 unstable sectors. Repeat on RG after its baseline map.</a:t>
                       </a:r>
                     </a:p>
                   </a:txBody>
@@ -10671,7 +10671,7 @@
                           </a:solidFill>
                           <a:latin typeface="Cambria"/>
                         </a:rPr>
-                        <a:t>30 minutes per radio</a:t>
+                        <a:t>done (30 min)</a:t>
                       </a:r>
                     </a:p>
                   </a:txBody>
@@ -12163,7 +12163,7 @@
                           </a:solidFill>
                           <a:latin typeface="Cambria"/>
                         </a:rPr>
-                        <a:t>Decisive sector test on SF (sheet 13): done 2026-10-27</a:t>
+                        <a:t>Decisive sector test on SF, then clean erase + re-provision: done 2026-10-27</a:t>
                       </a:r>
                     </a:p>
                   </a:txBody>
@@ -12185,7 +12185,7 @@
                           </a:solidFill>
                           <a:latin typeface="Cambria"/>
                         </a:rPr>
-                        <a:t>Outcome A: cells healthy after rewrite; fix 3 = clean erase</a:t>
+                        <a:t>Outcome A; after the clean erase the partition reads with 0 differing bytes across 3 reads</a:t>
                       </a:r>
                     </a:p>
                   </a:txBody>
@@ -13011,7 +13011,7 @@
                 </a:solidFill>
                 <a:latin typeface="Cambria"/>
               </a:rPr>
-              <a:t>unstable sectors in SF's settings flash, before and after one clean erase and reprogram</a:t>
+              <a:t>unstable sectors in SF's settings flash before and after the clean erase (measured, 2026-10-27)</a:t>
             </a:r>
           </a:p>
         </p:txBody>

</xml_diff>

<commit_message>
RG flash read-stability baseline: clean (0 unstable sectors); deck sheet 12/17 and manual verification record updated
Co-Authored-By: Claude Fable 5.1 <noreply@anthropic.com>
</commit_message>
<xml_diff>
--- a/docs/presentations/Group9_ConfigLoss_RootCause.pptx
+++ b/docs/presentations/Group9_ConfigLoss_RootCause.pptx
@@ -7928,7 +7928,7 @@
                 </a:solidFill>
                 <a:latin typeface="Cambria"/>
               </a:rPr>
-              <a:t>WHY SF AND NOT RG</a:t>
+              <a:t>WHY SF AND NOT RG: NOW MEASURED</a:t>
             </a:r>
           </a:p>
           <a:p>
@@ -7939,7 +7939,7 @@
                 </a:solidFill>
                 <a:latin typeface="Cambria"/>
               </a:rPr>
-              <a:t>Marginal cells are specific to one chip and one history. SF is the carried, bench-tested unit that has been run flat most often; RG reverted once, on the night both died. The sector map is a property of SF's history, not of the design, which is exactly why a hardware hypothesis was worth testing rather than dismissing.</a:t>
+              <a:t>Marginal cells are specific to one chip and one history. RG, measured the same way the same day, shows a clean map: 0 differing bytes across three reads of its settings partition, 112 sectors holding data, program partition stable, LittleFS mounting and decoding correctly. SF is the carried, bench-tested unit run flat most often and reverted three times; RG reverted once and shows no residue today. The scar follows the history, not the design.</a:t>
             </a:r>
           </a:p>
         </p:txBody>
@@ -12095,7 +12095,7 @@
                           </a:solidFill>
                           <a:latin typeface="Cambria"/>
                         </a:rPr>
-                        <a:t>Baseline flash map on both radios (today's method), archived</a:t>
+                        <a:t>Baseline flash map on both radios: done 2026-10-27</a:t>
                       </a:r>
                     </a:p>
                   </a:txBody>
@@ -12117,7 +12117,7 @@
                           </a:solidFill>
                           <a:latin typeface="Cambria"/>
                         </a:rPr>
-                        <a:t>RG map recorded; SF map as on sheet 10</a:t>
+                        <a:t>RG: 0 unstable sectors (clean). SF: 21 before repair, 0 after</a:t>
                       </a:r>
                     </a:p>
                   </a:txBody>

</xml_diff>